<commit_message>
Feedback form: a privacy line and a quote box
The subtitle now says what happens to the answers (typed up without
anything identifying, kept, group totals only, paper shredded), and a
tick box on the last row gives permission to quote. Exported from the
master in tools/printables; the Evaluation Toolkit describes both.

Co-Authored-By: Claude Opus 5.5 <noreply@anthropic.com>
</commit_message>
<xml_diff>
--- a/tools/printables/feedback-form.pptx
+++ b/tools/printables/feedback-form.pptx
@@ -3131,7 +3131,7 @@
         </p:nvSpPr>
         <p:spPr>
           <a:xfrm>
-            <a:off x="360000" y="576000"/>
+            <a:off x="360000" y="540000"/>
             <a:ext cx="6840000" cy="216000"/>
           </a:xfrm>
           <a:prstGeom prst="rect">
@@ -3153,7 +3153,7 @@
                 </a:solidFill>
                 <a:latin typeface="Aptos"/>
               </a:rPr>
-              <a:t>Anonymous. About three minutes. Thank you. (The grey labels are Kirkpatrick's levels: this form is Day 3 in practice.)</a:t>
+              <a:t>Anonymous: please don't add your name. We type up the answers without anything identifying, keep them to improve the programme, report only group totals and shred the paper. About three minutes. (Grey labels: Kirkpatrick's levels, so this form is Day 3 in practice.)</a:t>
             </a:r>
           </a:p>
         </p:txBody>
@@ -3816,7 +3816,7 @@
         </p:nvSpPr>
         <p:spPr>
           <a:xfrm>
-            <a:off x="360000" y="5832000"/>
+            <a:off x="360000" y="5796000"/>
             <a:ext cx="6840000" cy="216000"/>
           </a:xfrm>
           <a:prstGeom prst="rect">
@@ -3838,7 +3838,7 @@
                 </a:solidFill>
                 <a:latin typeface="Aptos"/>
               </a:rPr>
-              <a:t>Anonymous. About three minutes. Thank you. (The grey labels are Kirkpatrick's levels: this form is Day 3 in practice.)</a:t>
+              <a:t>Anonymous: please don't add your name. We type up the answers without anything identifying, keep them to improve the programme, report only group totals and shred the paper. About three minutes. (Grey labels: Kirkpatrick's levels, so this form is Day 3 in practice.)</a:t>
             </a:r>
           </a:p>
         </p:txBody>
@@ -4418,6 +4418,76 @@
                 <a:latin typeface="Aptos"/>
               </a:rPr>
               <a:t>Teaching That Lands · CC BY 4.0</a:t>
+            </a:r>
+          </a:p>
+        </p:txBody>
+      </p:sp>
+      <p:sp>
+        <p:nvSpPr>
+          <p:cNvPr id="5" name="TextBox 4"/>
+          <p:cNvSpPr txBox="1"/>
+          <p:nvPr/>
+        </p:nvSpPr>
+        <p:spPr>
+          <a:xfrm>
+            <a:off x="3960000" y="4644000"/>
+            <a:ext cx="3240000" cy="252000"/>
+          </a:xfrm>
+          <a:prstGeom prst="rect">
+            <a:avLst/>
+          </a:prstGeom>
+          <a:noFill/>
+        </p:spPr>
+        <p:txBody>
+          <a:bodyPr wrap="square" anchor="t" lIns="54000" rIns="54000" tIns="54000" bIns="54000">
+            <a:spAutoFit/>
+          </a:bodyPr>
+          <a:lstStyle/>
+          <a:p>
+            <a:pPr algn="r"/>
+            <a:r>
+              <a:rPr sz="900" b="0" i="0" u="none">
+                <a:solidFill>
+                  <a:srgbClr val="333333"/>
+                </a:solidFill>
+                <a:latin typeface="Aptos"/>
+              </a:rPr>
+              <a:t>▢  You can quote me (no name or workplace)</a:t>
+            </a:r>
+          </a:p>
+        </p:txBody>
+      </p:sp>
+      <p:sp>
+        <p:nvSpPr>
+          <p:cNvPr id="5" name="TextBox 4"/>
+          <p:cNvSpPr txBox="1"/>
+          <p:nvPr/>
+        </p:nvSpPr>
+        <p:spPr>
+          <a:xfrm>
+            <a:off x="3960000" y="9900000"/>
+            <a:ext cx="3240000" cy="252000"/>
+          </a:xfrm>
+          <a:prstGeom prst="rect">
+            <a:avLst/>
+          </a:prstGeom>
+          <a:noFill/>
+        </p:spPr>
+        <p:txBody>
+          <a:bodyPr wrap="square" anchor="t" lIns="54000" rIns="54000" tIns="54000" bIns="54000">
+            <a:spAutoFit/>
+          </a:bodyPr>
+          <a:lstStyle/>
+          <a:p>
+            <a:pPr algn="r"/>
+            <a:r>
+              <a:rPr sz="900" b="0" i="0" u="none">
+                <a:solidFill>
+                  <a:srgbClr val="333333"/>
+                </a:solidFill>
+                <a:latin typeface="Aptos"/>
+              </a:rPr>
+              <a:t>▢  You can quote me (no name or workplace)</a:t>
             </a:r>
           </a:p>
         </p:txBody>

</xml_diff>